<commit_message>
Rebuild Lao deck PPTX from edited lo.html
- 10 slides (one removed by user)
- Captured at 2x DPI (2560x1440 each) for crisper images in PowerPoint

Co-Authored-By: Claude Opus 4.7 (1M context) <noreply@anthropic.com>
</commit_message>
<xml_diff>
--- a/deck/SafeRide-Lao.pptx
+++ b/deck/SafeRide-Lao.pptx
@@ -15,7 +15,6 @@
     <p:sldId id="263" r:id="rId14"/>
     <p:sldId id="264" r:id="rId15"/>
     <p:sldId id="265" r:id="rId16"/>
-    <p:sldId id="266" r:id="rId17"/>
   </p:sldIdLst>
   <p:sldSz cx="12191695" cy="6858000" type="screen4x3"/>
   <p:notesSz cx="6858000" cy="9144000"/>
@@ -3143,48 +3142,6 @@
       <p:pic>
         <p:nvPicPr>
           <p:cNvPr id="2" name="Picture 1" descr="slide-10.png"/>
-          <p:cNvPicPr>
-            <a:picLocks noChangeAspect="1"/>
-          </p:cNvPicPr>
-          <p:nvPr/>
-        </p:nvPicPr>
-        <p:blipFill>
-          <a:blip r:embed="rId2"/>
-          <a:stretch>
-            <a:fillRect/>
-          </a:stretch>
-        </p:blipFill>
-        <p:spPr>
-          <a:xfrm>
-            <a:off x="0" y="0"/>
-            <a:ext cx="12191695" cy="6858000"/>
-          </a:xfrm>
-          <a:prstGeom prst="rect">
-            <a:avLst/>
-          </a:prstGeom>
-        </p:spPr>
-      </p:pic>
-    </p:spTree>
-  </p:cSld>
-  <p:clrMapOvr>
-    <a:masterClrMapping/>
-  </p:clrMapOvr>
-</p:sld>
-</file>
-
-<file path=ppt/slides/slide11.xml><?xml version="1.0" encoding="utf-8"?>
-<p:sld xmlns:a="http://schemas.openxmlformats.org/drawingml/2006/main" xmlns:p="http://schemas.openxmlformats.org/presentationml/2006/main" xmlns:r="http://schemas.openxmlformats.org/officeDocument/2006/relationships">
-  <p:cSld>
-    <p:spTree>
-      <p:nvGrpSpPr>
-        <p:cNvPr id="1" name=""/>
-        <p:cNvGrpSpPr/>
-        <p:nvPr/>
-      </p:nvGrpSpPr>
-      <p:grpSpPr/>
-      <p:pic>
-        <p:nvPicPr>
-          <p:cNvPr id="2" name="Picture 1" descr="slide-11.png"/>
           <p:cNvPicPr>
             <a:picLocks noChangeAspect="1"/>
           </p:cNvPicPr>

</xml_diff>